<commit_message>
feat: Noite 3 - prática de orçamento (3 slides + modelo de planilha .ods)
Co-Authored-By: Claude Opus 5.5 <noreply@anthropic.com>
Claude-Session: https://claude.ai/code/session_01K11yLGxmEHF1WcJYQgAV6R
</commit_message>
<xml_diff>
--- a/Aula - Redes 3 - Por onde o sinal viaja.pptx
+++ b/Aula - Redes 3 - Por onde o sinal viaja.pptx
@@ -30,6 +30,9 @@
     <p:sldId id="278" r:id="rId29"/>
     <p:sldId id="279" r:id="rId30"/>
     <p:sldId id="280" r:id="rId31"/>
+    <p:sldId id="281" r:id="rId32"/>
+    <p:sldId id="282" r:id="rId33"/>
+    <p:sldId id="283" r:id="rId34"/>
   </p:sldIdLst>
   <p:sldSz cx="12191695" cy="6858000" type="screen4x3"/>
   <p:notesSz cx="6858000" cy="9144000"/>
@@ -7481,7 +7484,7 @@
                   <a:srgbClr val="E88B1A"/>
                 </a:solidFill>
               </a:rPr>
-              <a:t>DUELO RELÂMPAGO · 15 MIN</a:t>
+              <a:t>PRÁTICA · 50 MIN</a:t>
             </a:r>
           </a:p>
         </p:txBody>
@@ -7515,7 +7518,7 @@
                   <a:srgbClr val="0B5C5C"/>
                 </a:solidFill>
               </a:rPr>
-              <a:t>Time A × Time B</a:t>
+              <a:t>Agora vocês são a empresa: monte o orçamento</a:t>
             </a:r>
           </a:p>
         </p:txBody>
@@ -7592,7 +7595,7 @@
                   <a:srgbClr val="1A1A1A"/>
                 </a:solidFill>
               </a:rPr>
-              <a:t>•  Turma dividida em dois times</a:t>
+              <a:t>•  Cada equipe orça 2 cenários (sorteio)</a:t>
             </a:r>
           </a:p>
           <a:p>
@@ -7603,7 +7606,7 @@
                   <a:srgbClr val="1A1A1A"/>
                 </a:solidFill>
               </a:rPr>
-              <a:t>•  Pergunta rápida, resposta em 5 segundos</a:t>
+              <a:t>•  Abram o modelo de planilha no LibreOffice Calc</a:t>
             </a:r>
           </a:p>
           <a:p>
@@ -7614,7 +7617,7 @@
                   <a:srgbClr val="1A1A1A"/>
                 </a:solidFill>
               </a:rPr>
-              <a:t>•  Alterna entre os times</a:t>
+              <a:t>•  Pesquisem preços reais na internet</a:t>
             </a:r>
           </a:p>
           <a:p>
@@ -7625,7 +7628,7 @@
                   <a:srgbClr val="1A1A1A"/>
                 </a:solidFill>
               </a:rPr>
-              <a:t>•  Ponto pra quem acertar</a:t>
+              <a:t/>
             </a:r>
           </a:p>
           <a:p>
@@ -7636,7 +7639,7 @@
                   <a:srgbClr val="1A1A1A"/>
                 </a:solidFill>
               </a:rPr>
-              <a:t>•  Empate = pergunta bônus</a:t>
+              <a:t>No final, cada equipe apresenta:</a:t>
             </a:r>
           </a:p>
           <a:p>
@@ -7647,18 +7650,7 @@
                   <a:srgbClr val="1A1A1A"/>
                 </a:solidFill>
               </a:rPr>
-              <a:t/>
-            </a:r>
-          </a:p>
-          <a:p>
-            <a:pPr algn="l"/>
-            <a:r>
-              <a:rPr sz="1900" b="0" i="0">
-                <a:solidFill>
-                  <a:srgbClr val="1A1A1A"/>
-                </a:solidFill>
-              </a:rPr>
-              <a:t>Regra: se a resposta demorar mais de 5 segundos, passa pro outro time.</a:t>
+              <a:t>     a solução  ·  o valor total  ·  o porquê</a:t>
             </a:r>
           </a:p>
         </p:txBody>
@@ -7787,7 +7779,7 @@
                   <a:srgbClr val="E88B1A"/>
                 </a:solidFill>
               </a:rPr>
-              <a:t>O RESUMO DA NOITE</a:t>
+              <a:t>REGRAS DO ORÇAMENTO</a:t>
             </a:r>
           </a:p>
         </p:txBody>
@@ -7821,7 +7813,7 @@
                   <a:srgbClr val="0B5C5C"/>
                 </a:solidFill>
               </a:rPr>
-              <a:t>Quatro ideias que ficam</a:t>
+              <a:t>O que não pode faltar</a:t>
             </a:r>
           </a:p>
         </p:txBody>
@@ -7877,8 +7869,8 @@
         </p:nvSpPr>
         <p:spPr>
           <a:xfrm>
-            <a:off x="640080" y="2743200"/>
-            <a:ext cx="10881360" cy="3200400"/>
+            <a:off x="640080" y="2560320"/>
+            <a:ext cx="10881360" cy="2926080"/>
           </a:xfrm>
           <a:prstGeom prst="rect">
             <a:avLst/>
@@ -7898,7 +7890,7 @@
                   <a:srgbClr val="1A1A1A"/>
                 </a:solidFill>
               </a:rPr>
-              <a:t>•  Existem só três meios de transmissão: cabo, fibra e ondas</a:t>
+              <a:t>✔  Link de cada item — de onde veio o preço</a:t>
             </a:r>
           </a:p>
           <a:p>
@@ -7909,7 +7901,7 @@
                   <a:srgbClr val="1A1A1A"/>
                 </a:solidFill>
               </a:rPr>
-              <a:t>•  Cabo é padrão pra conexão fixa e curta. Fibra pra longa distância. Onda pra quem se mexe.</a:t>
+              <a:t>✔  Quantidade pensada — quantos metros? quantos conectores?</a:t>
             </a:r>
           </a:p>
           <a:p>
@@ -7920,7 +7912,7 @@
                   <a:srgbClr val="1A1A1A"/>
                 </a:solidFill>
               </a:rPr>
-              <a:t>•  Cat5e ou Cat6 resolve a casa comum. Não venda Cat6a sem motivo.</a:t>
+              <a:t>✔  Frete — ou "retirada na loja"</a:t>
             </a:r>
           </a:p>
           <a:p>
@@ -7931,7 +7923,18 @@
                   <a:srgbClr val="1A1A1A"/>
                 </a:solidFill>
               </a:rPr>
-              <a:t>•  A capa do cabo conta tudo — marca, categoria, tipo e metragem.</a:t>
+              <a:t>✔  Mão de obra — técnico não trabalha de graça</a:t>
+            </a:r>
+          </a:p>
+          <a:p>
+            <a:pPr algn="l"/>
+            <a:r>
+              <a:rPr sz="1900" b="0" i="0">
+                <a:solidFill>
+                  <a:srgbClr val="1A1A1A"/>
+                </a:solidFill>
+              </a:rPr>
+              <a:t>✔  Justificativa — por que essa solução e não outra?</a:t>
             </a:r>
           </a:p>
         </p:txBody>
@@ -7939,6 +7942,40 @@
       <p:sp>
         <p:nvSpPr>
           <p:cNvPr id="7" name="TextBox 6"/>
+          <p:cNvSpPr txBox="1"/>
+          <p:nvPr/>
+        </p:nvSpPr>
+        <p:spPr>
+          <a:xfrm>
+            <a:off x="640080" y="5669280"/>
+            <a:ext cx="10881360" cy="457200"/>
+          </a:xfrm>
+          <a:prstGeom prst="rect">
+            <a:avLst/>
+          </a:prstGeom>
+          <a:noFill/>
+        </p:spPr>
+        <p:txBody>
+          <a:bodyPr wrap="square" lIns="0" rIns="0" tIns="0" bIns="0" anchor="t">
+            <a:spAutoFit/>
+          </a:bodyPr>
+          <a:lstStyle/>
+          <a:p>
+            <a:pPr algn="ctr"/>
+            <a:r>
+              <a:rPr sz="1700" b="1" i="1">
+                <a:solidFill>
+                  <a:srgbClr val="C5362B"/>
+                </a:solidFill>
+              </a:rPr>
+              <a:t>Orçamento sem link e sem justificativa não vale ponto.</a:t>
+            </a:r>
+          </a:p>
+        </p:txBody>
+      </p:sp>
+      <p:sp>
+        <p:nvSpPr>
+          <p:cNvPr id="8" name="TextBox 7"/>
           <p:cNvSpPr txBox="1"/>
           <p:nvPr/>
         </p:nvSpPr>
@@ -8060,7 +8097,7 @@
                   <a:srgbClr val="E88B1A"/>
                 </a:solidFill>
               </a:rPr>
-              <a:t>FECHANDO</a:t>
+              <a:t>DEBATE</a:t>
             </a:r>
           </a:p>
         </p:txBody>
@@ -8094,7 +8131,7 @@
                   <a:srgbClr val="0B5C5C"/>
                 </a:solidFill>
               </a:rPr>
-              <a:t>Cinco perguntas para conferir</a:t>
+              <a:t>Mesmo problema, preços diferentes. Por quê?</a:t>
             </a:r>
           </a:p>
         </p:txBody>
@@ -8151,7 +8188,7 @@
         <p:spPr>
           <a:xfrm>
             <a:off x="640080" y="2560320"/>
-            <a:ext cx="10881360" cy="3657600"/>
+            <a:ext cx="10881360" cy="2926080"/>
           </a:xfrm>
           <a:prstGeom prst="rect">
             <a:avLst/>
@@ -8166,56 +8203,56 @@
           <a:p>
             <a:pPr algn="l"/>
             <a:r>
-              <a:rPr sz="1700" b="0" i="0">
-                <a:solidFill>
-                  <a:srgbClr val="1A1A1A"/>
-                </a:solidFill>
-              </a:rPr>
-              <a:t>1. Como você reconhece um cabo par trançado sem abrir a capa?</a:t>
-            </a:r>
-          </a:p>
-          <a:p>
-            <a:pPr algn="l"/>
-            <a:r>
-              <a:rPr sz="1700" b="0" i="0">
-                <a:solidFill>
-                  <a:srgbClr val="1A1A1A"/>
-                </a:solidFill>
-              </a:rPr>
-              <a:t>2. Diferença entre Cat5e e Cat6, na prática?</a:t>
-            </a:r>
-          </a:p>
-          <a:p>
-            <a:pPr algn="l"/>
-            <a:r>
-              <a:rPr sz="1700" b="0" i="0">
-                <a:solidFill>
-                  <a:srgbClr val="1A1A1A"/>
-                </a:solidFill>
-              </a:rPr>
-              <a:t>3. Fibra ou cabo pra uma sala 8 m de distância?</a:t>
-            </a:r>
-          </a:p>
-          <a:p>
-            <a:pPr algn="l"/>
-            <a:r>
-              <a:rPr sz="1700" b="0" i="0">
-                <a:solidFill>
-                  <a:srgbClr val="1A1A1A"/>
-                </a:solidFill>
-              </a:rPr>
-              <a:t>4. 5 GHz é melhor ou pior que 2,4 GHz? Depende do quê?</a:t>
-            </a:r>
-          </a:p>
-          <a:p>
-            <a:pPr algn="l"/>
-            <a:r>
-              <a:rPr sz="1700" b="0" i="0">
-                <a:solidFill>
-                  <a:srgbClr val="1A1A1A"/>
-                </a:solidFill>
-              </a:rPr>
-              <a:t>5. Cliente diz "vizinho tá roubando meu Wi-Fi". O que a aula ajuda a entender?</a:t>
+              <a:rPr sz="1900" b="0" i="0">
+                <a:solidFill>
+                  <a:srgbClr val="1A1A1A"/>
+                </a:solidFill>
+              </a:rPr>
+              <a:t>•  Metragem diferente?</a:t>
+            </a:r>
+          </a:p>
+          <a:p>
+            <a:pPr algn="l"/>
+            <a:r>
+              <a:rPr sz="1900" b="0" i="0">
+                <a:solidFill>
+                  <a:srgbClr val="1A1A1A"/>
+                </a:solidFill>
+              </a:rPr>
+              <a:t>•  Cat5e ou Cat6?</a:t>
+            </a:r>
+          </a:p>
+          <a:p>
+            <a:pPr algn="l"/>
+            <a:r>
+              <a:rPr sz="1900" b="0" i="0">
+                <a:solidFill>
+                  <a:srgbClr val="1A1A1A"/>
+                </a:solidFill>
+              </a:rPr>
+              <a:t>•  Loja diferente?</a:t>
+            </a:r>
+          </a:p>
+          <a:p>
+            <a:pPr algn="l"/>
+            <a:r>
+              <a:rPr sz="1900" b="0" i="0">
+                <a:solidFill>
+                  <a:srgbClr val="1A1A1A"/>
+                </a:solidFill>
+              </a:rPr>
+              <a:t>•  Equipamento mais caro do que precisava?</a:t>
+            </a:r>
+          </a:p>
+          <a:p>
+            <a:pPr algn="l"/>
+            <a:r>
+              <a:rPr sz="1900" b="0" i="0">
+                <a:solidFill>
+                  <a:srgbClr val="1A1A1A"/>
+                </a:solidFill>
+              </a:rPr>
+              <a:t>•  Alguém esqueceu algum item?</a:t>
             </a:r>
           </a:p>
         </p:txBody>
@@ -8223,6 +8260,40 @@
       <p:sp>
         <p:nvSpPr>
           <p:cNvPr id="7" name="TextBox 6"/>
+          <p:cNvSpPr txBox="1"/>
+          <p:nvPr/>
+        </p:nvSpPr>
+        <p:spPr>
+          <a:xfrm>
+            <a:off x="640080" y="5669280"/>
+            <a:ext cx="10881360" cy="457200"/>
+          </a:xfrm>
+          <a:prstGeom prst="rect">
+            <a:avLst/>
+          </a:prstGeom>
+          <a:noFill/>
+        </p:spPr>
+        <p:txBody>
+          <a:bodyPr wrap="square" lIns="0" rIns="0" tIns="0" bIns="0" anchor="t">
+            <a:spAutoFit/>
+          </a:bodyPr>
+          <a:lstStyle/>
+          <a:p>
+            <a:pPr algn="ctr"/>
+            <a:r>
+              <a:rPr sz="2000" b="1" i="0">
+                <a:solidFill>
+                  <a:srgbClr val="0B5C5C"/>
+                </a:solidFill>
+              </a:rPr>
+              <a:t>Se você fosse o cliente, contrataria qual equipe?</a:t>
+            </a:r>
+          </a:p>
+        </p:txBody>
+      </p:sp>
+      <p:sp>
+        <p:nvSpPr>
+          <p:cNvPr id="8" name="TextBox 7"/>
           <p:cNvSpPr txBox="1"/>
           <p:nvPr/>
         </p:nvSpPr>
@@ -8344,7 +8415,7 @@
                   <a:srgbClr val="E88B1A"/>
                 </a:solidFill>
               </a:rPr>
-              <a:t>O QUE FICA DESTA NOITE</a:t>
+              <a:t>DUELO RELÂMPAGO · 15 MIN</a:t>
             </a:r>
           </a:p>
         </p:txBody>
@@ -8378,7 +8449,7 @@
                   <a:srgbClr val="0B5C5C"/>
                 </a:solidFill>
               </a:rPr>
-              <a:t>Cinco coisas para levar</a:t>
+              <a:t>Time A × Time B</a:t>
             </a:r>
           </a:p>
         </p:txBody>
@@ -8435,7 +8506,7 @@
         <p:spPr>
           <a:xfrm>
             <a:off x="640080" y="2560320"/>
-            <a:ext cx="10881360" cy="3840480"/>
+            <a:ext cx="10881360" cy="3657600"/>
           </a:xfrm>
           <a:prstGeom prst="rect">
             <a:avLst/>
@@ -8450,56 +8521,78 @@
           <a:p>
             <a:pPr algn="l"/>
             <a:r>
-              <a:rPr sz="1700" b="0" i="0">
-                <a:solidFill>
-                  <a:srgbClr val="1A1A1A"/>
-                </a:solidFill>
-              </a:rPr>
-              <a:t>•  Três meios: cabo, fibra, ondas. Cada um resolve num lugar.</a:t>
-            </a:r>
-          </a:p>
-          <a:p>
-            <a:pPr algn="l"/>
-            <a:r>
-              <a:rPr sz="1700" b="0" i="0">
-                <a:solidFill>
-                  <a:srgbClr val="1A1A1A"/>
-                </a:solidFill>
-              </a:rPr>
-              <a:t>•  Cabo par trançado: 8 fios, 4 pares. Não destrance na ponta.</a:t>
-            </a:r>
-          </a:p>
-          <a:p>
-            <a:pPr algn="l"/>
-            <a:r>
-              <a:rPr sz="1700" b="0" i="0">
-                <a:solidFill>
-                  <a:srgbClr val="1A1A1A"/>
-                </a:solidFill>
-              </a:rPr>
-              <a:t>•  Cat5e ou Cat6 pra casa. Blindado só onde tem interferência de indústria.</a:t>
-            </a:r>
-          </a:p>
-          <a:p>
-            <a:pPr algn="l"/>
-            <a:r>
-              <a:rPr sz="1700" b="0" i="0">
-                <a:solidFill>
-                  <a:srgbClr val="1A1A1A"/>
-                </a:solidFill>
-              </a:rPr>
-              <a:t>•  Wi-Fi tem duas faixas: 2,4 GHz (alcance) e 5 GHz (velocidade).</a:t>
-            </a:r>
-          </a:p>
-          <a:p>
-            <a:pPr algn="l"/>
-            <a:r>
-              <a:rPr sz="1700" b="0" i="0">
-                <a:solidFill>
-                  <a:srgbClr val="1A1A1A"/>
-                </a:solidFill>
-              </a:rPr>
-              <a:t>•  A capa do cabo tem tudo que você precisa — marca, categoria e a metragem.</a:t>
+              <a:rPr sz="1900" b="0" i="0">
+                <a:solidFill>
+                  <a:srgbClr val="1A1A1A"/>
+                </a:solidFill>
+              </a:rPr>
+              <a:t>•  Turma dividida em dois times</a:t>
+            </a:r>
+          </a:p>
+          <a:p>
+            <a:pPr algn="l"/>
+            <a:r>
+              <a:rPr sz="1900" b="0" i="0">
+                <a:solidFill>
+                  <a:srgbClr val="1A1A1A"/>
+                </a:solidFill>
+              </a:rPr>
+              <a:t>•  Pergunta rápida, resposta em 5 segundos</a:t>
+            </a:r>
+          </a:p>
+          <a:p>
+            <a:pPr algn="l"/>
+            <a:r>
+              <a:rPr sz="1900" b="0" i="0">
+                <a:solidFill>
+                  <a:srgbClr val="1A1A1A"/>
+                </a:solidFill>
+              </a:rPr>
+              <a:t>•  Alterna entre os times</a:t>
+            </a:r>
+          </a:p>
+          <a:p>
+            <a:pPr algn="l"/>
+            <a:r>
+              <a:rPr sz="1900" b="0" i="0">
+                <a:solidFill>
+                  <a:srgbClr val="1A1A1A"/>
+                </a:solidFill>
+              </a:rPr>
+              <a:t>•  Ponto pra quem acertar</a:t>
+            </a:r>
+          </a:p>
+          <a:p>
+            <a:pPr algn="l"/>
+            <a:r>
+              <a:rPr sz="1900" b="0" i="0">
+                <a:solidFill>
+                  <a:srgbClr val="1A1A1A"/>
+                </a:solidFill>
+              </a:rPr>
+              <a:t>•  Empate = pergunta bônus</a:t>
+            </a:r>
+          </a:p>
+          <a:p>
+            <a:pPr algn="l"/>
+            <a:r>
+              <a:rPr sz="1900" b="0" i="0">
+                <a:solidFill>
+                  <a:srgbClr val="1A1A1A"/>
+                </a:solidFill>
+              </a:rPr>
+              <a:t/>
+            </a:r>
+          </a:p>
+          <a:p>
+            <a:pPr algn="l"/>
+            <a:r>
+              <a:rPr sz="1900" b="0" i="0">
+                <a:solidFill>
+                  <a:srgbClr val="1A1A1A"/>
+                </a:solidFill>
+              </a:rPr>
+              <a:t>Regra: se a resposta demorar mais de 5 segundos, passa pro outro time.</a:t>
             </a:r>
           </a:p>
         </p:txBody>
@@ -8547,6 +8640,847 @@
 </file>
 
 <file path=ppt/slides/slide25.xml><?xml version="1.0" encoding="utf-8"?>
+<p:sld xmlns:a="http://schemas.openxmlformats.org/drawingml/2006/main" xmlns:p="http://schemas.openxmlformats.org/presentationml/2006/main" xmlns:r="http://schemas.openxmlformats.org/officeDocument/2006/relationships">
+  <p:cSld>
+    <p:spTree>
+      <p:nvGrpSpPr>
+        <p:cNvPr id="1" name=""/>
+        <p:cNvGrpSpPr/>
+        <p:nvPr/>
+      </p:nvGrpSpPr>
+      <p:grpSpPr/>
+      <p:sp>
+        <p:nvSpPr>
+          <p:cNvPr id="2" name="Rectangle 1"/>
+          <p:cNvSpPr/>
+          <p:nvPr/>
+        </p:nvSpPr>
+        <p:spPr>
+          <a:xfrm>
+            <a:off x="0" y="0"/>
+            <a:ext cx="12191695" cy="6858000"/>
+          </a:xfrm>
+          <a:prstGeom prst="rect">
+            <a:avLst/>
+          </a:prstGeom>
+          <a:solidFill>
+            <a:srgbClr val="F4F7F7"/>
+          </a:solidFill>
+          <a:ln>
+            <a:noFill/>
+          </a:ln>
+        </p:spPr>
+        <p:style>
+          <a:lnRef idx="1">
+            <a:schemeClr val="accent1"/>
+          </a:lnRef>
+          <a:fillRef idx="3">
+            <a:schemeClr val="accent1"/>
+          </a:fillRef>
+          <a:effectRef idx="2">
+            <a:schemeClr val="accent1"/>
+          </a:effectRef>
+          <a:fontRef idx="minor">
+            <a:schemeClr val="lt1"/>
+          </a:fontRef>
+        </p:style>
+        <p:txBody>
+          <a:bodyPr rtlCol="0" anchor="ctr"/>
+          <a:lstStyle/>
+          <a:p>
+            <a:pPr algn="ctr"/>
+          </a:p>
+        </p:txBody>
+      </p:sp>
+      <p:sp>
+        <p:nvSpPr>
+          <p:cNvPr id="3" name="TextBox 2"/>
+          <p:cNvSpPr txBox="1"/>
+          <p:nvPr/>
+        </p:nvSpPr>
+        <p:spPr>
+          <a:xfrm>
+            <a:off x="640080" y="365760"/>
+            <a:ext cx="10881360" cy="320040"/>
+          </a:xfrm>
+          <a:prstGeom prst="rect">
+            <a:avLst/>
+          </a:prstGeom>
+          <a:noFill/>
+        </p:spPr>
+        <p:txBody>
+          <a:bodyPr wrap="square" lIns="0" rIns="0" tIns="0" bIns="0" anchor="t">
+            <a:spAutoFit/>
+          </a:bodyPr>
+          <a:lstStyle/>
+          <a:p>
+            <a:pPr algn="l"/>
+            <a:r>
+              <a:rPr sz="1300" b="1" i="0">
+                <a:solidFill>
+                  <a:srgbClr val="E88B1A"/>
+                </a:solidFill>
+              </a:rPr>
+              <a:t>O RESUMO DA NOITE</a:t>
+            </a:r>
+          </a:p>
+        </p:txBody>
+      </p:sp>
+      <p:sp>
+        <p:nvSpPr>
+          <p:cNvPr id="4" name="TextBox 3"/>
+          <p:cNvSpPr txBox="1"/>
+          <p:nvPr/>
+        </p:nvSpPr>
+        <p:spPr>
+          <a:xfrm>
+            <a:off x="640080" y="685800"/>
+            <a:ext cx="10881360" cy="822960"/>
+          </a:xfrm>
+          <a:prstGeom prst="rect">
+            <a:avLst/>
+          </a:prstGeom>
+          <a:noFill/>
+        </p:spPr>
+        <p:txBody>
+          <a:bodyPr wrap="square" lIns="0" rIns="0" tIns="0" bIns="0" anchor="t">
+            <a:spAutoFit/>
+          </a:bodyPr>
+          <a:lstStyle/>
+          <a:p>
+            <a:pPr algn="l"/>
+            <a:r>
+              <a:rPr sz="3400" b="1" i="0">
+                <a:solidFill>
+                  <a:srgbClr val="0B5C5C"/>
+                </a:solidFill>
+              </a:rPr>
+              <a:t>Quatro ideias que ficam</a:t>
+            </a:r>
+          </a:p>
+        </p:txBody>
+      </p:sp>
+      <p:sp>
+        <p:nvSpPr>
+          <p:cNvPr id="5" name="Rectangle 4"/>
+          <p:cNvSpPr/>
+          <p:nvPr/>
+        </p:nvSpPr>
+        <p:spPr>
+          <a:xfrm>
+            <a:off x="640080" y="1554480"/>
+            <a:ext cx="10881360" cy="54864"/>
+          </a:xfrm>
+          <a:prstGeom prst="rect">
+            <a:avLst/>
+          </a:prstGeom>
+          <a:solidFill>
+            <a:srgbClr val="0B5C5C"/>
+          </a:solidFill>
+          <a:ln>
+            <a:noFill/>
+          </a:ln>
+        </p:spPr>
+        <p:style>
+          <a:lnRef idx="1">
+            <a:schemeClr val="accent1"/>
+          </a:lnRef>
+          <a:fillRef idx="3">
+            <a:schemeClr val="accent1"/>
+          </a:fillRef>
+          <a:effectRef idx="2">
+            <a:schemeClr val="accent1"/>
+          </a:effectRef>
+          <a:fontRef idx="minor">
+            <a:schemeClr val="lt1"/>
+          </a:fontRef>
+        </p:style>
+        <p:txBody>
+          <a:bodyPr rtlCol="0" anchor="ctr"/>
+          <a:lstStyle/>
+          <a:p>
+            <a:pPr algn="ctr"/>
+          </a:p>
+        </p:txBody>
+      </p:sp>
+      <p:sp>
+        <p:nvSpPr>
+          <p:cNvPr id="6" name="TextBox 5"/>
+          <p:cNvSpPr txBox="1"/>
+          <p:nvPr/>
+        </p:nvSpPr>
+        <p:spPr>
+          <a:xfrm>
+            <a:off x="640080" y="2743200"/>
+            <a:ext cx="10881360" cy="3200400"/>
+          </a:xfrm>
+          <a:prstGeom prst="rect">
+            <a:avLst/>
+          </a:prstGeom>
+          <a:noFill/>
+        </p:spPr>
+        <p:txBody>
+          <a:bodyPr wrap="square" lIns="0" rIns="0" tIns="0" bIns="0" anchor="t">
+            <a:spAutoFit/>
+          </a:bodyPr>
+          <a:lstStyle/>
+          <a:p>
+            <a:pPr algn="l"/>
+            <a:r>
+              <a:rPr sz="1900" b="0" i="0">
+                <a:solidFill>
+                  <a:srgbClr val="1A1A1A"/>
+                </a:solidFill>
+              </a:rPr>
+              <a:t>•  Existem só três meios de transmissão: cabo, fibra e ondas</a:t>
+            </a:r>
+          </a:p>
+          <a:p>
+            <a:pPr algn="l"/>
+            <a:r>
+              <a:rPr sz="1900" b="0" i="0">
+                <a:solidFill>
+                  <a:srgbClr val="1A1A1A"/>
+                </a:solidFill>
+              </a:rPr>
+              <a:t>•  Cabo é padrão pra conexão fixa e curta. Fibra pra longa distância. Onda pra quem se mexe.</a:t>
+            </a:r>
+          </a:p>
+          <a:p>
+            <a:pPr algn="l"/>
+            <a:r>
+              <a:rPr sz="1900" b="0" i="0">
+                <a:solidFill>
+                  <a:srgbClr val="1A1A1A"/>
+                </a:solidFill>
+              </a:rPr>
+              <a:t>•  Cat5e ou Cat6 resolve a casa comum. Não venda Cat6a sem motivo.</a:t>
+            </a:r>
+          </a:p>
+          <a:p>
+            <a:pPr algn="l"/>
+            <a:r>
+              <a:rPr sz="1900" b="0" i="0">
+                <a:solidFill>
+                  <a:srgbClr val="1A1A1A"/>
+                </a:solidFill>
+              </a:rPr>
+              <a:t>•  A capa do cabo conta tudo — marca, categoria, tipo e metragem.</a:t>
+            </a:r>
+          </a:p>
+        </p:txBody>
+      </p:sp>
+      <p:sp>
+        <p:nvSpPr>
+          <p:cNvPr id="7" name="TextBox 6"/>
+          <p:cNvSpPr txBox="1"/>
+          <p:nvPr/>
+        </p:nvSpPr>
+        <p:spPr>
+          <a:xfrm>
+            <a:off x="640080" y="6446520"/>
+            <a:ext cx="10881360" cy="274320"/>
+          </a:xfrm>
+          <a:prstGeom prst="rect">
+            <a:avLst/>
+          </a:prstGeom>
+          <a:noFill/>
+        </p:spPr>
+        <p:txBody>
+          <a:bodyPr wrap="square" lIns="0" rIns="0" tIns="0" bIns="0" anchor="t">
+            <a:spAutoFit/>
+          </a:bodyPr>
+          <a:lstStyle/>
+          <a:p>
+            <a:pPr algn="l"/>
+            <a:r>
+              <a:rPr sz="1000" b="0" i="1">
+                <a:solidFill>
+                  <a:srgbClr val="555555"/>
+                </a:solidFill>
+              </a:rPr>
+              <a:t>Redes de Computadores · Noite 3</a:t>
+            </a:r>
+          </a:p>
+        </p:txBody>
+      </p:sp>
+    </p:spTree>
+  </p:cSld>
+  <p:clrMapOvr>
+    <a:masterClrMapping/>
+  </p:clrMapOvr>
+</p:sld>
+</file>
+
+<file path=ppt/slides/slide26.xml><?xml version="1.0" encoding="utf-8"?>
+<p:sld xmlns:a="http://schemas.openxmlformats.org/drawingml/2006/main" xmlns:p="http://schemas.openxmlformats.org/presentationml/2006/main" xmlns:r="http://schemas.openxmlformats.org/officeDocument/2006/relationships">
+  <p:cSld>
+    <p:spTree>
+      <p:nvGrpSpPr>
+        <p:cNvPr id="1" name=""/>
+        <p:cNvGrpSpPr/>
+        <p:nvPr/>
+      </p:nvGrpSpPr>
+      <p:grpSpPr/>
+      <p:sp>
+        <p:nvSpPr>
+          <p:cNvPr id="2" name="Rectangle 1"/>
+          <p:cNvSpPr/>
+          <p:nvPr/>
+        </p:nvSpPr>
+        <p:spPr>
+          <a:xfrm>
+            <a:off x="0" y="0"/>
+            <a:ext cx="12191695" cy="6858000"/>
+          </a:xfrm>
+          <a:prstGeom prst="rect">
+            <a:avLst/>
+          </a:prstGeom>
+          <a:solidFill>
+            <a:srgbClr val="F4F7F7"/>
+          </a:solidFill>
+          <a:ln>
+            <a:noFill/>
+          </a:ln>
+        </p:spPr>
+        <p:style>
+          <a:lnRef idx="1">
+            <a:schemeClr val="accent1"/>
+          </a:lnRef>
+          <a:fillRef idx="3">
+            <a:schemeClr val="accent1"/>
+          </a:fillRef>
+          <a:effectRef idx="2">
+            <a:schemeClr val="accent1"/>
+          </a:effectRef>
+          <a:fontRef idx="minor">
+            <a:schemeClr val="lt1"/>
+          </a:fontRef>
+        </p:style>
+        <p:txBody>
+          <a:bodyPr rtlCol="0" anchor="ctr"/>
+          <a:lstStyle/>
+          <a:p>
+            <a:pPr algn="ctr"/>
+          </a:p>
+        </p:txBody>
+      </p:sp>
+      <p:sp>
+        <p:nvSpPr>
+          <p:cNvPr id="3" name="TextBox 2"/>
+          <p:cNvSpPr txBox="1"/>
+          <p:nvPr/>
+        </p:nvSpPr>
+        <p:spPr>
+          <a:xfrm>
+            <a:off x="640080" y="365760"/>
+            <a:ext cx="10881360" cy="320040"/>
+          </a:xfrm>
+          <a:prstGeom prst="rect">
+            <a:avLst/>
+          </a:prstGeom>
+          <a:noFill/>
+        </p:spPr>
+        <p:txBody>
+          <a:bodyPr wrap="square" lIns="0" rIns="0" tIns="0" bIns="0" anchor="t">
+            <a:spAutoFit/>
+          </a:bodyPr>
+          <a:lstStyle/>
+          <a:p>
+            <a:pPr algn="l"/>
+            <a:r>
+              <a:rPr sz="1300" b="1" i="0">
+                <a:solidFill>
+                  <a:srgbClr val="E88B1A"/>
+                </a:solidFill>
+              </a:rPr>
+              <a:t>FECHANDO</a:t>
+            </a:r>
+          </a:p>
+        </p:txBody>
+      </p:sp>
+      <p:sp>
+        <p:nvSpPr>
+          <p:cNvPr id="4" name="TextBox 3"/>
+          <p:cNvSpPr txBox="1"/>
+          <p:nvPr/>
+        </p:nvSpPr>
+        <p:spPr>
+          <a:xfrm>
+            <a:off x="640080" y="685800"/>
+            <a:ext cx="10881360" cy="822960"/>
+          </a:xfrm>
+          <a:prstGeom prst="rect">
+            <a:avLst/>
+          </a:prstGeom>
+          <a:noFill/>
+        </p:spPr>
+        <p:txBody>
+          <a:bodyPr wrap="square" lIns="0" rIns="0" tIns="0" bIns="0" anchor="t">
+            <a:spAutoFit/>
+          </a:bodyPr>
+          <a:lstStyle/>
+          <a:p>
+            <a:pPr algn="l"/>
+            <a:r>
+              <a:rPr sz="3400" b="1" i="0">
+                <a:solidFill>
+                  <a:srgbClr val="0B5C5C"/>
+                </a:solidFill>
+              </a:rPr>
+              <a:t>Cinco perguntas para conferir</a:t>
+            </a:r>
+          </a:p>
+        </p:txBody>
+      </p:sp>
+      <p:sp>
+        <p:nvSpPr>
+          <p:cNvPr id="5" name="Rectangle 4"/>
+          <p:cNvSpPr/>
+          <p:nvPr/>
+        </p:nvSpPr>
+        <p:spPr>
+          <a:xfrm>
+            <a:off x="640080" y="1554480"/>
+            <a:ext cx="10881360" cy="54864"/>
+          </a:xfrm>
+          <a:prstGeom prst="rect">
+            <a:avLst/>
+          </a:prstGeom>
+          <a:solidFill>
+            <a:srgbClr val="0B5C5C"/>
+          </a:solidFill>
+          <a:ln>
+            <a:noFill/>
+          </a:ln>
+        </p:spPr>
+        <p:style>
+          <a:lnRef idx="1">
+            <a:schemeClr val="accent1"/>
+          </a:lnRef>
+          <a:fillRef idx="3">
+            <a:schemeClr val="accent1"/>
+          </a:fillRef>
+          <a:effectRef idx="2">
+            <a:schemeClr val="accent1"/>
+          </a:effectRef>
+          <a:fontRef idx="minor">
+            <a:schemeClr val="lt1"/>
+          </a:fontRef>
+        </p:style>
+        <p:txBody>
+          <a:bodyPr rtlCol="0" anchor="ctr"/>
+          <a:lstStyle/>
+          <a:p>
+            <a:pPr algn="ctr"/>
+          </a:p>
+        </p:txBody>
+      </p:sp>
+      <p:sp>
+        <p:nvSpPr>
+          <p:cNvPr id="6" name="TextBox 5"/>
+          <p:cNvSpPr txBox="1"/>
+          <p:nvPr/>
+        </p:nvSpPr>
+        <p:spPr>
+          <a:xfrm>
+            <a:off x="640080" y="2560320"/>
+            <a:ext cx="10881360" cy="3657600"/>
+          </a:xfrm>
+          <a:prstGeom prst="rect">
+            <a:avLst/>
+          </a:prstGeom>
+          <a:noFill/>
+        </p:spPr>
+        <p:txBody>
+          <a:bodyPr wrap="square" lIns="0" rIns="0" tIns="0" bIns="0" anchor="t">
+            <a:spAutoFit/>
+          </a:bodyPr>
+          <a:lstStyle/>
+          <a:p>
+            <a:pPr algn="l"/>
+            <a:r>
+              <a:rPr sz="1700" b="0" i="0">
+                <a:solidFill>
+                  <a:srgbClr val="1A1A1A"/>
+                </a:solidFill>
+              </a:rPr>
+              <a:t>1. Como você reconhece um cabo par trançado sem abrir a capa?</a:t>
+            </a:r>
+          </a:p>
+          <a:p>
+            <a:pPr algn="l"/>
+            <a:r>
+              <a:rPr sz="1700" b="0" i="0">
+                <a:solidFill>
+                  <a:srgbClr val="1A1A1A"/>
+                </a:solidFill>
+              </a:rPr>
+              <a:t>2. Diferença entre Cat5e e Cat6, na prática?</a:t>
+            </a:r>
+          </a:p>
+          <a:p>
+            <a:pPr algn="l"/>
+            <a:r>
+              <a:rPr sz="1700" b="0" i="0">
+                <a:solidFill>
+                  <a:srgbClr val="1A1A1A"/>
+                </a:solidFill>
+              </a:rPr>
+              <a:t>3. Fibra ou cabo pra uma sala 8 m de distância?</a:t>
+            </a:r>
+          </a:p>
+          <a:p>
+            <a:pPr algn="l"/>
+            <a:r>
+              <a:rPr sz="1700" b="0" i="0">
+                <a:solidFill>
+                  <a:srgbClr val="1A1A1A"/>
+                </a:solidFill>
+              </a:rPr>
+              <a:t>4. 5 GHz é melhor ou pior que 2,4 GHz? Depende do quê?</a:t>
+            </a:r>
+          </a:p>
+          <a:p>
+            <a:pPr algn="l"/>
+            <a:r>
+              <a:rPr sz="1700" b="0" i="0">
+                <a:solidFill>
+                  <a:srgbClr val="1A1A1A"/>
+                </a:solidFill>
+              </a:rPr>
+              <a:t>5. Cliente diz "vizinho tá roubando meu Wi-Fi". O que a aula ajuda a entender?</a:t>
+            </a:r>
+          </a:p>
+        </p:txBody>
+      </p:sp>
+      <p:sp>
+        <p:nvSpPr>
+          <p:cNvPr id="7" name="TextBox 6"/>
+          <p:cNvSpPr txBox="1"/>
+          <p:nvPr/>
+        </p:nvSpPr>
+        <p:spPr>
+          <a:xfrm>
+            <a:off x="640080" y="6446520"/>
+            <a:ext cx="10881360" cy="274320"/>
+          </a:xfrm>
+          <a:prstGeom prst="rect">
+            <a:avLst/>
+          </a:prstGeom>
+          <a:noFill/>
+        </p:spPr>
+        <p:txBody>
+          <a:bodyPr wrap="square" lIns="0" rIns="0" tIns="0" bIns="0" anchor="t">
+            <a:spAutoFit/>
+          </a:bodyPr>
+          <a:lstStyle/>
+          <a:p>
+            <a:pPr algn="l"/>
+            <a:r>
+              <a:rPr sz="1000" b="0" i="1">
+                <a:solidFill>
+                  <a:srgbClr val="555555"/>
+                </a:solidFill>
+              </a:rPr>
+              <a:t>Redes de Computadores · Noite 3</a:t>
+            </a:r>
+          </a:p>
+        </p:txBody>
+      </p:sp>
+    </p:spTree>
+  </p:cSld>
+  <p:clrMapOvr>
+    <a:masterClrMapping/>
+  </p:clrMapOvr>
+</p:sld>
+</file>
+
+<file path=ppt/slides/slide27.xml><?xml version="1.0" encoding="utf-8"?>
+<p:sld xmlns:a="http://schemas.openxmlformats.org/drawingml/2006/main" xmlns:p="http://schemas.openxmlformats.org/presentationml/2006/main" xmlns:r="http://schemas.openxmlformats.org/officeDocument/2006/relationships">
+  <p:cSld>
+    <p:spTree>
+      <p:nvGrpSpPr>
+        <p:cNvPr id="1" name=""/>
+        <p:cNvGrpSpPr/>
+        <p:nvPr/>
+      </p:nvGrpSpPr>
+      <p:grpSpPr/>
+      <p:sp>
+        <p:nvSpPr>
+          <p:cNvPr id="2" name="Rectangle 1"/>
+          <p:cNvSpPr/>
+          <p:nvPr/>
+        </p:nvSpPr>
+        <p:spPr>
+          <a:xfrm>
+            <a:off x="0" y="0"/>
+            <a:ext cx="12191695" cy="6858000"/>
+          </a:xfrm>
+          <a:prstGeom prst="rect">
+            <a:avLst/>
+          </a:prstGeom>
+          <a:solidFill>
+            <a:srgbClr val="F4F7F7"/>
+          </a:solidFill>
+          <a:ln>
+            <a:noFill/>
+          </a:ln>
+        </p:spPr>
+        <p:style>
+          <a:lnRef idx="1">
+            <a:schemeClr val="accent1"/>
+          </a:lnRef>
+          <a:fillRef idx="3">
+            <a:schemeClr val="accent1"/>
+          </a:fillRef>
+          <a:effectRef idx="2">
+            <a:schemeClr val="accent1"/>
+          </a:effectRef>
+          <a:fontRef idx="minor">
+            <a:schemeClr val="lt1"/>
+          </a:fontRef>
+        </p:style>
+        <p:txBody>
+          <a:bodyPr rtlCol="0" anchor="ctr"/>
+          <a:lstStyle/>
+          <a:p>
+            <a:pPr algn="ctr"/>
+          </a:p>
+        </p:txBody>
+      </p:sp>
+      <p:sp>
+        <p:nvSpPr>
+          <p:cNvPr id="3" name="TextBox 2"/>
+          <p:cNvSpPr txBox="1"/>
+          <p:nvPr/>
+        </p:nvSpPr>
+        <p:spPr>
+          <a:xfrm>
+            <a:off x="640080" y="365760"/>
+            <a:ext cx="10881360" cy="320040"/>
+          </a:xfrm>
+          <a:prstGeom prst="rect">
+            <a:avLst/>
+          </a:prstGeom>
+          <a:noFill/>
+        </p:spPr>
+        <p:txBody>
+          <a:bodyPr wrap="square" lIns="0" rIns="0" tIns="0" bIns="0" anchor="t">
+            <a:spAutoFit/>
+          </a:bodyPr>
+          <a:lstStyle/>
+          <a:p>
+            <a:pPr algn="l"/>
+            <a:r>
+              <a:rPr sz="1300" b="1" i="0">
+                <a:solidFill>
+                  <a:srgbClr val="E88B1A"/>
+                </a:solidFill>
+              </a:rPr>
+              <a:t>O QUE FICA DESTA NOITE</a:t>
+            </a:r>
+          </a:p>
+        </p:txBody>
+      </p:sp>
+      <p:sp>
+        <p:nvSpPr>
+          <p:cNvPr id="4" name="TextBox 3"/>
+          <p:cNvSpPr txBox="1"/>
+          <p:nvPr/>
+        </p:nvSpPr>
+        <p:spPr>
+          <a:xfrm>
+            <a:off x="640080" y="685800"/>
+            <a:ext cx="10881360" cy="822960"/>
+          </a:xfrm>
+          <a:prstGeom prst="rect">
+            <a:avLst/>
+          </a:prstGeom>
+          <a:noFill/>
+        </p:spPr>
+        <p:txBody>
+          <a:bodyPr wrap="square" lIns="0" rIns="0" tIns="0" bIns="0" anchor="t">
+            <a:spAutoFit/>
+          </a:bodyPr>
+          <a:lstStyle/>
+          <a:p>
+            <a:pPr algn="l"/>
+            <a:r>
+              <a:rPr sz="3400" b="1" i="0">
+                <a:solidFill>
+                  <a:srgbClr val="0B5C5C"/>
+                </a:solidFill>
+              </a:rPr>
+              <a:t>Cinco coisas para levar</a:t>
+            </a:r>
+          </a:p>
+        </p:txBody>
+      </p:sp>
+      <p:sp>
+        <p:nvSpPr>
+          <p:cNvPr id="5" name="Rectangle 4"/>
+          <p:cNvSpPr/>
+          <p:nvPr/>
+        </p:nvSpPr>
+        <p:spPr>
+          <a:xfrm>
+            <a:off x="640080" y="1554480"/>
+            <a:ext cx="10881360" cy="54864"/>
+          </a:xfrm>
+          <a:prstGeom prst="rect">
+            <a:avLst/>
+          </a:prstGeom>
+          <a:solidFill>
+            <a:srgbClr val="0B5C5C"/>
+          </a:solidFill>
+          <a:ln>
+            <a:noFill/>
+          </a:ln>
+        </p:spPr>
+        <p:style>
+          <a:lnRef idx="1">
+            <a:schemeClr val="accent1"/>
+          </a:lnRef>
+          <a:fillRef idx="3">
+            <a:schemeClr val="accent1"/>
+          </a:fillRef>
+          <a:effectRef idx="2">
+            <a:schemeClr val="accent1"/>
+          </a:effectRef>
+          <a:fontRef idx="minor">
+            <a:schemeClr val="lt1"/>
+          </a:fontRef>
+        </p:style>
+        <p:txBody>
+          <a:bodyPr rtlCol="0" anchor="ctr"/>
+          <a:lstStyle/>
+          <a:p>
+            <a:pPr algn="ctr"/>
+          </a:p>
+        </p:txBody>
+      </p:sp>
+      <p:sp>
+        <p:nvSpPr>
+          <p:cNvPr id="6" name="TextBox 5"/>
+          <p:cNvSpPr txBox="1"/>
+          <p:nvPr/>
+        </p:nvSpPr>
+        <p:spPr>
+          <a:xfrm>
+            <a:off x="640080" y="2560320"/>
+            <a:ext cx="10881360" cy="3840480"/>
+          </a:xfrm>
+          <a:prstGeom prst="rect">
+            <a:avLst/>
+          </a:prstGeom>
+          <a:noFill/>
+        </p:spPr>
+        <p:txBody>
+          <a:bodyPr wrap="square" lIns="0" rIns="0" tIns="0" bIns="0" anchor="t">
+            <a:spAutoFit/>
+          </a:bodyPr>
+          <a:lstStyle/>
+          <a:p>
+            <a:pPr algn="l"/>
+            <a:r>
+              <a:rPr sz="1700" b="0" i="0">
+                <a:solidFill>
+                  <a:srgbClr val="1A1A1A"/>
+                </a:solidFill>
+              </a:rPr>
+              <a:t>•  Três meios: cabo, fibra, ondas. Cada um resolve num lugar.</a:t>
+            </a:r>
+          </a:p>
+          <a:p>
+            <a:pPr algn="l"/>
+            <a:r>
+              <a:rPr sz="1700" b="0" i="0">
+                <a:solidFill>
+                  <a:srgbClr val="1A1A1A"/>
+                </a:solidFill>
+              </a:rPr>
+              <a:t>•  Cabo par trançado: 8 fios, 4 pares. Não destrance na ponta.</a:t>
+            </a:r>
+          </a:p>
+          <a:p>
+            <a:pPr algn="l"/>
+            <a:r>
+              <a:rPr sz="1700" b="0" i="0">
+                <a:solidFill>
+                  <a:srgbClr val="1A1A1A"/>
+                </a:solidFill>
+              </a:rPr>
+              <a:t>•  Cat5e ou Cat6 pra casa. Blindado só onde tem interferência de indústria.</a:t>
+            </a:r>
+          </a:p>
+          <a:p>
+            <a:pPr algn="l"/>
+            <a:r>
+              <a:rPr sz="1700" b="0" i="0">
+                <a:solidFill>
+                  <a:srgbClr val="1A1A1A"/>
+                </a:solidFill>
+              </a:rPr>
+              <a:t>•  Wi-Fi tem duas faixas: 2,4 GHz (alcance) e 5 GHz (velocidade).</a:t>
+            </a:r>
+          </a:p>
+          <a:p>
+            <a:pPr algn="l"/>
+            <a:r>
+              <a:rPr sz="1700" b="0" i="0">
+                <a:solidFill>
+                  <a:srgbClr val="1A1A1A"/>
+                </a:solidFill>
+              </a:rPr>
+              <a:t>•  A capa do cabo tem tudo que você precisa — marca, categoria e a metragem.</a:t>
+            </a:r>
+          </a:p>
+        </p:txBody>
+      </p:sp>
+      <p:sp>
+        <p:nvSpPr>
+          <p:cNvPr id="7" name="TextBox 6"/>
+          <p:cNvSpPr txBox="1"/>
+          <p:nvPr/>
+        </p:nvSpPr>
+        <p:spPr>
+          <a:xfrm>
+            <a:off x="640080" y="6446520"/>
+            <a:ext cx="10881360" cy="274320"/>
+          </a:xfrm>
+          <a:prstGeom prst="rect">
+            <a:avLst/>
+          </a:prstGeom>
+          <a:noFill/>
+        </p:spPr>
+        <p:txBody>
+          <a:bodyPr wrap="square" lIns="0" rIns="0" tIns="0" bIns="0" anchor="t">
+            <a:spAutoFit/>
+          </a:bodyPr>
+          <a:lstStyle/>
+          <a:p>
+            <a:pPr algn="l"/>
+            <a:r>
+              <a:rPr sz="1000" b="0" i="1">
+                <a:solidFill>
+                  <a:srgbClr val="555555"/>
+                </a:solidFill>
+              </a:rPr>
+              <a:t>Redes de Computadores · Noite 3</a:t>
+            </a:r>
+          </a:p>
+        </p:txBody>
+      </p:sp>
+    </p:spTree>
+  </p:cSld>
+  <p:clrMapOvr>
+    <a:masterClrMapping/>
+  </p:clrMapOvr>
+</p:sld>
+</file>
+
+<file path=ppt/slides/slide28.xml><?xml version="1.0" encoding="utf-8"?>
 <p:sld xmlns:a="http://schemas.openxmlformats.org/drawingml/2006/main" xmlns:p="http://schemas.openxmlformats.org/presentationml/2006/main" xmlns:r="http://schemas.openxmlformats.org/officeDocument/2006/relationships">
   <p:cSld>
     <p:spTree>

</xml_diff>